<commit_message>
docs: replace slide four with concrete three-source field example
</commit_message>
<xml_diff>
--- a/docs/彼岸物理规律发现挑战赛_课题介绍.pptx
+++ b/docs/彼岸物理规律发现挑战赛_课题介绍.pptx
@@ -6542,7 +6542,7 @@
                 <a:latin typeface="微软雅黑"/>
                 <a:ea typeface="微软雅黑"/>
               </a:rPr>
-              <a:t>实验方式：向彼岸投放探针</a:t>
+              <a:t>三 彼岸宇宙多体力场示例</a:t>
             </a:r>
             <a:endParaRPr lang="zh-CN" sz="3600"/>
           </a:p>
@@ -6603,14 +6603,110 @@
       </p:pic>
       <p:sp>
         <p:nvSpPr>
-          <p:cNvPr id="30" name="示意画布"/>
+          <p:cNvPr id="30" name="二维说明_用户原文"/>
           <p:cNvSpPr txBox="1"/>
           <p:nvPr/>
         </p:nvSpPr>
         <p:spPr>
           <a:xfrm>
-            <a:off x="762000" y="1562100"/>
-            <a:ext cx="5486400" cy="3898900"/>
+            <a:off x="762000" y="1422400"/>
+            <a:ext cx="10668000" cy="736600"/>
+          </a:xfrm>
+          <a:prstGeom prst="rect">
+            <a:avLst/>
+          </a:prstGeom>
+          <a:noFill/>
+          <a:ln w="12700">
+            <a:noFill/>
+          </a:ln>
+        </p:spPr>
+        <p:txBody>
+          <a:bodyPr wrap="square" lIns="0" rIns="0" tIns="0" bIns="0" anchor="t">
+            <a:noAutofit/>
+          </a:bodyPr>
+          <a:lstStyle/>
+          <a:p>
+            <a:pPr algn="l">
+              <a:lnSpc>
+                <a:spcPct val="110000"/>
+              </a:lnSpc>
+              <a:spcAft>
+                <a:spcPts val="700"/>
+              </a:spcAft>
+              <a:buNone/>
+            </a:pPr>
+            <a:r>
+              <a:rPr lang="zh-CN" sz="1900" b="0" dirty="0">
+                <a:solidFill>
+                  <a:srgbClr val="243746"/>
+                </a:solidFill>
+                <a:latin typeface="微软雅黑"/>
+                <a:ea typeface="微软雅黑"/>
+              </a:rPr>
+              <a:t>注：此部分用于说明彼岸宇宙的存在形式，即可以将彼岸宇宙简单视作具有不同规律的多体力场，且所有宇宙的空间维数均为2。</a:t>
+            </a:r>
+            <a:endParaRPr lang="zh-CN" sz="1900"/>
+          </a:p>
+        </p:txBody>
+      </p:sp>
+      <p:sp>
+        <p:nvSpPr>
+          <p:cNvPr id="31" name="教学示例范围_用户原文"/>
+          <p:cNvSpPr txBox="1"/>
+          <p:nvPr/>
+        </p:nvSpPr>
+        <p:spPr>
+          <a:xfrm>
+            <a:off x="762000" y="2273300"/>
+            <a:ext cx="10668000" cy="749300"/>
+          </a:xfrm>
+          <a:prstGeom prst="rect">
+            <a:avLst/>
+          </a:prstGeom>
+          <a:noFill/>
+          <a:ln w="12700">
+            <a:noFill/>
+          </a:ln>
+        </p:spPr>
+        <p:txBody>
+          <a:bodyPr wrap="square" lIns="0" rIns="0" tIns="0" bIns="0" anchor="t">
+            <a:noAutofit/>
+          </a:bodyPr>
+          <a:lstStyle/>
+          <a:p>
+            <a:pPr algn="l">
+              <a:lnSpc>
+                <a:spcPct val="110000"/>
+              </a:lnSpc>
+              <a:spcAft>
+                <a:spcPts val="700"/>
+              </a:spcAft>
+              <a:buNone/>
+            </a:pPr>
+            <a:r>
+              <a:rPr lang="zh-CN" sz="1900" b="0" dirty="0">
+                <a:solidFill>
+                  <a:srgbClr val="243746"/>
+                </a:solidFill>
+                <a:latin typeface="微软雅黑"/>
+                <a:ea typeface="微软雅黑"/>
+              </a:rPr>
+              <a:t>以三个固定可见天体和一枚运动探针为例，说明实验方式。此例不属于九个正式宇宙；这里公开公式仅用于讲解，正式宇宙的规律需要从观测中推断。</a:t>
+            </a:r>
+            <a:endParaRPr lang="zh-CN" sz="1900"/>
+          </a:p>
+        </p:txBody>
+      </p:sp>
+      <p:sp>
+        <p:nvSpPr>
+          <p:cNvPr id="32" name="三源示意画布"/>
+          <p:cNvSpPr txBox="1"/>
+          <p:nvPr/>
+        </p:nvSpPr>
+        <p:spPr>
+          <a:xfrm>
+            <a:off x="762000" y="3086100"/>
+            <a:ext cx="4318000" cy="2286000"/>
           </a:xfrm>
           <a:prstGeom prst="rect">
             <a:avLst/>
@@ -6627,14 +6723,14 @@
       </p:sp>
       <p:sp>
         <p:nvSpPr>
-          <p:cNvPr id="31" name="图示标题"/>
+          <p:cNvPr id="33" name="图例_用户原文"/>
           <p:cNvSpPr txBox="1"/>
           <p:nvPr/>
         </p:nvSpPr>
         <p:spPr>
           <a:xfrm>
-            <a:off x="977900" y="1739900"/>
-            <a:ext cx="4889500" cy="342900"/>
+            <a:off x="762000" y="5473700"/>
+            <a:ext cx="4318000" cy="546100"/>
           </a:xfrm>
           <a:prstGeom prst="rect">
             <a:avLst/>
@@ -6660,73 +6756,29 @@
               <a:buNone/>
             </a:pPr>
             <a:r>
-              <a:rPr lang="zh-CN" sz="1800" b="0" dirty="0">
+              <a:rPr lang="zh-CN" sz="1600" b="0" dirty="0">
                 <a:solidFill>
                   <a:srgbClr val="576B7E"/>
                 </a:solidFill>
                 <a:latin typeface="微软雅黑"/>
                 <a:ea typeface="微软雅黑"/>
               </a:rPr>
-              <a:t>二维宇宙 · 实验示意</a:t>
-            </a:r>
-            <a:endParaRPr lang="zh-CN" sz="1800"/>
-          </a:p>
-        </p:txBody>
-      </p:sp>
-      <p:sp>
-        <p:nvSpPr>
-          <p:cNvPr id="32" name="可见天体A"/>
+              <a:t>蓝点为可见天体；橙色曲线为探针运动，圆点表示采样时刻。</a:t>
+            </a:r>
+            <a:endParaRPr lang="zh-CN" sz="1600"/>
+          </a:p>
+        </p:txBody>
+      </p:sp>
+      <p:sp>
+        <p:nvSpPr>
+          <p:cNvPr id="34" name="力场小标题_用户原文"/>
           <p:cNvSpPr txBox="1"/>
           <p:nvPr/>
         </p:nvSpPr>
         <p:spPr>
           <a:xfrm>
-            <a:off x="1689100" y="2908300"/>
-            <a:ext cx="482600" cy="482600"/>
-          </a:xfrm>
-          <a:prstGeom prst="ellipse">
-            <a:avLst/>
-          </a:prstGeom>
-          <a:solidFill>
-            <a:srgbClr val="1A9BB1"/>
-          </a:solidFill>
-          <a:ln w="12700">
-            <a:noFill/>
-          </a:ln>
-        </p:spPr>
-      </p:sp>
-      <p:sp>
-        <p:nvSpPr>
-          <p:cNvPr id="33" name="可见天体B"/>
-          <p:cNvSpPr txBox="1"/>
-          <p:nvPr/>
-        </p:nvSpPr>
-        <p:spPr>
-          <a:xfrm>
-            <a:off x="4406900" y="2286000"/>
-            <a:ext cx="317500" cy="317500"/>
-          </a:xfrm>
-          <a:prstGeom prst="ellipse">
-            <a:avLst/>
-          </a:prstGeom>
-          <a:solidFill>
-            <a:srgbClr val="6EBBC6"/>
-          </a:solidFill>
-          <a:ln w="12700">
-            <a:noFill/>
-          </a:ln>
-        </p:spPr>
-      </p:sp>
-      <p:sp>
-        <p:nvSpPr>
-          <p:cNvPr id="34" name="可见背景标签"/>
-          <p:cNvSpPr txBox="1"/>
-          <p:nvPr/>
-        </p:nvSpPr>
-        <p:spPr>
-          <a:xfrm>
-            <a:off x="1181100" y="3568700"/>
-            <a:ext cx="1651000" cy="381000"/>
+            <a:off x="5397500" y="3136900"/>
+            <a:ext cx="6032500" cy="419100"/>
           </a:xfrm>
           <a:prstGeom prst="rect">
             <a:avLst/>
@@ -6742,7 +6794,7 @@
           </a:bodyPr>
           <a:lstStyle/>
           <a:p>
-            <a:pPr algn="ctr">
+            <a:pPr algn="l">
               <a:lnSpc>
                 <a:spcPct val="110000"/>
               </a:lnSpc>
@@ -6752,162 +6804,512 @@
               <a:buNone/>
             </a:pPr>
             <a:r>
-              <a:rPr lang="zh-CN" sz="1900" b="0" dirty="0">
+              <a:rPr lang="zh-CN" sz="2400" b="1" dirty="0">
                 <a:solidFill>
                   <a:srgbClr val="335693"/>
                 </a:solidFill>
                 <a:latin typeface="微软雅黑"/>
                 <a:ea typeface="微软雅黑"/>
               </a:rPr>
-              <a:t>可见天体</a:t>
-            </a:r>
-            <a:endParaRPr lang="zh-CN" sz="1900"/>
-          </a:p>
-        </p:txBody>
-      </p:sp>
-      <p:cxnSp>
-        <p:nvCxnSpPr>
-          <p:cNvPr id="35" name="背景标线"/>
-          <p:cNvCxnSpPr/>
+              <a:t>力场如何作用</a:t>
+            </a:r>
+            <a:endParaRPr lang="zh-CN" sz="2400"/>
+          </a:p>
+        </p:txBody>
+      </p:sp>
+      <p:sp>
+        <p:nvSpPr>
+          <p:cNvPr id="35" name="源坐标与叠加_用户原文"/>
+          <p:cNvSpPr txBox="1"/>
           <p:nvPr/>
-        </p:nvCxnSpPr>
-        <p:spPr>
-          <a:xfrm flipH="1" flipV="1">
-            <a:off x="1943100" y="3403600"/>
-            <a:ext cx="38100" cy="63500"/>
-          </a:xfrm>
-          <a:prstGeom prst="line">
+        </p:nvSpPr>
+        <p:spPr>
+          <a:xfrm>
+            <a:off x="5397500" y="3695700"/>
+            <a:ext cx="6032500" cy="1155700"/>
+          </a:xfrm>
+          <a:prstGeom prst="rect">
             <a:avLst/>
           </a:prstGeom>
+          <a:noFill/>
           <a:ln w="12700">
+            <a:noFill/>
+          </a:ln>
+        </p:spPr>
+        <p:txBody>
+          <a:bodyPr wrap="square" lIns="0" rIns="0" tIns="0" bIns="0" anchor="t">
+            <a:noAutofit/>
+          </a:bodyPr>
+          <a:lstStyle/>
+          <a:p>
+            <a:pPr algn="l">
+              <a:lnSpc>
+                <a:spcPct val="110000"/>
+              </a:lnSpc>
+              <a:spcAft>
+                <a:spcPts val="700"/>
+              </a:spcAft>
+              <a:buNone/>
+            </a:pPr>
+            <a:r>
+              <a:rPr lang="zh-CN" sz="2000" b="0" dirty="0">
+                <a:solidFill>
+                  <a:srgbClr val="243746"/>
+                </a:solidFill>
+                <a:latin typeface="微软雅黑"/>
+                <a:ea typeface="微软雅黑"/>
+              </a:rPr>
+              <a:t>三个等强作用源的位置为 b₁ = (−2, 0)、b₂ = (2, 0)、b₃ = (0, 3)。探针位置为 r，加速度是三个源作用的叠加：</a:t>
+            </a:r>
+            <a:endParaRPr lang="zh-CN" sz="2000"/>
+          </a:p>
+        </p:txBody>
+      </p:sp>
+      <p:sp>
+        <p:nvSpPr>
+          <p:cNvPr id="36" name="加速度公式_用户原文"/>
+          <p:cNvSpPr txBox="1"/>
+          <p:nvPr/>
+        </p:nvSpPr>
+        <p:spPr>
+          <a:xfrm>
+            <a:off x="5397500" y="4940300"/>
+            <a:ext cx="6032500" cy="660400"/>
+          </a:xfrm>
+          <a:prstGeom prst="rect">
+            <a:avLst/>
+          </a:prstGeom>
+          <a:noFill/>
+          <a:ln w="12700">
+            <a:noFill/>
+          </a:ln>
+        </p:spPr>
+        <p:txBody>
+          <a:bodyPr wrap="square" lIns="0" rIns="0" tIns="0" bIns="0" anchor="t">
+            <a:noAutofit/>
+          </a:bodyPr>
+          <a:lstStyle/>
+          <a:p>
+            <a:pPr algn="l">
+              <a:lnSpc>
+                <a:spcPct val="110000"/>
+              </a:lnSpc>
+              <a:spcAft>
+                <a:spcPts val="700"/>
+              </a:spcAft>
+              <a:buNone/>
+            </a:pPr>
+            <a:r>
+              <a:rPr lang="zh-CN" sz="2200" b="1" dirty="0">
+                <a:solidFill>
+                  <a:srgbClr val="335693"/>
+                </a:solidFill>
+                <a:latin typeface="Cambria Math"/>
+                <a:ea typeface="Cambria Math"/>
+              </a:rPr>
+              <a:t>𝑎(𝑟) = 0.1 [(𝑏₁ − 𝑟) + (𝑏₂ − 𝑟) + (𝑏₃ − 𝑟)]</a:t>
+            </a:r>
+            <a:endParaRPr lang="zh-CN" sz="2200"/>
+          </a:p>
+        </p:txBody>
+      </p:sp>
+      <p:sp>
+        <p:nvSpPr>
+          <p:cNvPr id="37" name="力场机制说明_用户原文"/>
+          <p:cNvSpPr txBox="1"/>
+          <p:nvPr/>
+        </p:nvSpPr>
+        <p:spPr>
+          <a:xfrm>
+            <a:off x="762000" y="6070600"/>
+            <a:ext cx="10668000" cy="647700"/>
+          </a:xfrm>
+          <a:prstGeom prst="rect">
+            <a:avLst/>
+          </a:prstGeom>
+          <a:noFill/>
+          <a:ln w="12700">
+            <a:noFill/>
+          </a:ln>
+        </p:spPr>
+        <p:txBody>
+          <a:bodyPr wrap="square" lIns="0" rIns="0" tIns="0" bIns="0" anchor="t">
+            <a:noAutofit/>
+          </a:bodyPr>
+          <a:lstStyle/>
+          <a:p>
+            <a:pPr algn="l">
+              <a:lnSpc>
+                <a:spcPct val="110000"/>
+              </a:lnSpc>
+              <a:spcAft>
+                <a:spcPts val="700"/>
+              </a:spcAft>
+              <a:buNone/>
+            </a:pPr>
+            <a:r>
+              <a:rPr lang="zh-CN" sz="1900" b="0" dirty="0">
+                <a:solidFill>
+                  <a:srgbClr val="243746"/>
+                </a:solidFill>
+                <a:latin typeface="微软雅黑"/>
+                <a:ea typeface="微软雅黑"/>
+              </a:rPr>
+              <a:t>每个源的作用指向该源，大小正比于距离的一次方。源位置固定，没有额外外加场或周期调制；固定位置上的力场不随时间变化。</a:t>
+            </a:r>
+            <a:endParaRPr lang="zh-CN" sz="1900"/>
+          </a:p>
+        </p:txBody>
+      </p:sp>
+      <p:sp>
+        <p:nvSpPr>
+          <p:cNvPr id="38" name="探针真实解析轨迹"/>
+          <p:cNvSpPr txBox="1"/>
+          <p:nvPr/>
+        </p:nvSpPr>
+        <p:spPr>
+          <a:xfrm>
+            <a:off x="1549400" y="3619910"/>
+            <a:ext cx="2517137" cy="704144"/>
+          </a:xfrm>
+          <a:custGeom>
+            <a:avLst/>
+            <a:gdLst/>
+            <a:ahLst/>
+            <a:cxnLst/>
+            <a:rect l="l" t="t" r="r" b="b"/>
+            <a:pathLst>
+              <a:path w="2517137" h="704144" fill="none" stroke="1" extrusionOk="0">
+                <a:moveTo>
+                  <a:pt x="0" y="591410"/>
+                </a:moveTo>
+                <a:lnTo>
+                  <a:pt x="14226" y="570969"/>
+                </a:lnTo>
+                <a:lnTo>
+                  <a:pt x="29586" y="550623"/>
+                </a:lnTo>
+                <a:lnTo>
+                  <a:pt x="46065" y="530393"/>
+                </a:lnTo>
+                <a:lnTo>
+                  <a:pt x="63648" y="510296"/>
+                </a:lnTo>
+                <a:lnTo>
+                  <a:pt x="82318" y="490352"/>
+                </a:lnTo>
+                <a:lnTo>
+                  <a:pt x="102057" y="470580"/>
+                </a:lnTo>
+                <a:lnTo>
+                  <a:pt x="122847" y="450997"/>
+                </a:lnTo>
+                <a:lnTo>
+                  <a:pt x="144668" y="431623"/>
+                </a:lnTo>
+                <a:lnTo>
+                  <a:pt x="167501" y="412476"/>
+                </a:lnTo>
+                <a:lnTo>
+                  <a:pt x="191322" y="393574"/>
+                </a:lnTo>
+                <a:lnTo>
+                  <a:pt x="216111" y="374935"/>
+                </a:lnTo>
+                <a:lnTo>
+                  <a:pt x="241843" y="356575"/>
+                </a:lnTo>
+                <a:lnTo>
+                  <a:pt x="268495" y="338513"/>
+                </a:lnTo>
+                <a:lnTo>
+                  <a:pt x="296041" y="320765"/>
+                </a:lnTo>
+                <a:lnTo>
+                  <a:pt x="324455" y="303349"/>
+                </a:lnTo>
+                <a:lnTo>
+                  <a:pt x="353711" y="286279"/>
+                </a:lnTo>
+                <a:lnTo>
+                  <a:pt x="383782" y="269574"/>
+                </a:lnTo>
+                <a:lnTo>
+                  <a:pt x="414638" y="253247"/>
+                </a:lnTo>
+                <a:lnTo>
+                  <a:pt x="446251" y="237315"/>
+                </a:lnTo>
+                <a:lnTo>
+                  <a:pt x="478592" y="221793"/>
+                </a:lnTo>
+                <a:lnTo>
+                  <a:pt x="511629" y="206695"/>
+                </a:lnTo>
+                <a:lnTo>
+                  <a:pt x="545331" y="192035"/>
+                </a:lnTo>
+                <a:lnTo>
+                  <a:pt x="579668" y="177827"/>
+                </a:lnTo>
+                <a:lnTo>
+                  <a:pt x="614606" y="164085"/>
+                </a:lnTo>
+                <a:lnTo>
+                  <a:pt x="650113" y="150821"/>
+                </a:lnTo>
+                <a:lnTo>
+                  <a:pt x="686155" y="138049"/>
+                </a:lnTo>
+                <a:lnTo>
+                  <a:pt x="722699" y="125779"/>
+                </a:lnTo>
+                <a:lnTo>
+                  <a:pt x="759710" y="114023"/>
+                </a:lnTo>
+                <a:lnTo>
+                  <a:pt x="797153" y="102794"/>
+                </a:lnTo>
+                <a:lnTo>
+                  <a:pt x="834993" y="92100"/>
+                </a:lnTo>
+                <a:lnTo>
+                  <a:pt x="873194" y="81953"/>
+                </a:lnTo>
+                <a:lnTo>
+                  <a:pt x="911721" y="72361"/>
+                </a:lnTo>
+                <a:lnTo>
+                  <a:pt x="950537" y="63334"/>
+                </a:lnTo>
+                <a:lnTo>
+                  <a:pt x="989606" y="54880"/>
+                </a:lnTo>
+                <a:lnTo>
+                  <a:pt x="1028891" y="47008"/>
+                </a:lnTo>
+                <a:lnTo>
+                  <a:pt x="1068355" y="39724"/>
+                </a:lnTo>
+                <a:lnTo>
+                  <a:pt x="1107961" y="33035"/>
+                </a:lnTo>
+                <a:lnTo>
+                  <a:pt x="1147672" y="26948"/>
+                </a:lnTo>
+                <a:lnTo>
+                  <a:pt x="1187450" y="21469"/>
+                </a:lnTo>
+                <a:lnTo>
+                  <a:pt x="1227258" y="16602"/>
+                </a:lnTo>
+                <a:lnTo>
+                  <a:pt x="1267058" y="12353"/>
+                </a:lnTo>
+                <a:lnTo>
+                  <a:pt x="1306813" y="8725"/>
+                </a:lnTo>
+                <a:lnTo>
+                  <a:pt x="1346485" y="5721"/>
+                </a:lnTo>
+                <a:lnTo>
+                  <a:pt x="1386038" y="3345"/>
+                </a:lnTo>
+                <a:lnTo>
+                  <a:pt x="1425434" y="1598"/>
+                </a:lnTo>
+                <a:lnTo>
+                  <a:pt x="1464636" y="483"/>
+                </a:lnTo>
+                <a:lnTo>
+                  <a:pt x="1503608" y="0"/>
+                </a:lnTo>
+                <a:lnTo>
+                  <a:pt x="1542311" y="150"/>
+                </a:lnTo>
+                <a:lnTo>
+                  <a:pt x="1580711" y="933"/>
+                </a:lnTo>
+                <a:lnTo>
+                  <a:pt x="1618770" y="2347"/>
+                </a:lnTo>
+                <a:lnTo>
+                  <a:pt x="1656454" y="4392"/>
+                </a:lnTo>
+                <a:lnTo>
+                  <a:pt x="1693726" y="7066"/>
+                </a:lnTo>
+                <a:lnTo>
+                  <a:pt x="1730552" y="10366"/>
+                </a:lnTo>
+                <a:lnTo>
+                  <a:pt x="1766897" y="14289"/>
+                </a:lnTo>
+                <a:lnTo>
+                  <a:pt x="1802727" y="18832"/>
+                </a:lnTo>
+                <a:lnTo>
+                  <a:pt x="1838007" y="23989"/>
+                </a:lnTo>
+                <a:lnTo>
+                  <a:pt x="1872706" y="29757"/>
+                </a:lnTo>
+                <a:lnTo>
+                  <a:pt x="1906790" y="36129"/>
+                </a:lnTo>
+                <a:lnTo>
+                  <a:pt x="1940227" y="43101"/>
+                </a:lnTo>
+                <a:lnTo>
+                  <a:pt x="1972985" y="50665"/>
+                </a:lnTo>
+                <a:lnTo>
+                  <a:pt x="2005035" y="58813"/>
+                </a:lnTo>
+                <a:lnTo>
+                  <a:pt x="2036345" y="67540"/>
+                </a:lnTo>
+                <a:lnTo>
+                  <a:pt x="2066887" y="76835"/>
+                </a:lnTo>
+                <a:lnTo>
+                  <a:pt x="2096631" y="86692"/>
+                </a:lnTo>
+                <a:lnTo>
+                  <a:pt x="2125550" y="97099"/>
+                </a:lnTo>
+                <a:lnTo>
+                  <a:pt x="2153616" y="108048"/>
+                </a:lnTo>
+                <a:lnTo>
+                  <a:pt x="2180803" y="119528"/>
+                </a:lnTo>
+                <a:lnTo>
+                  <a:pt x="2207085" y="131529"/>
+                </a:lnTo>
+                <a:lnTo>
+                  <a:pt x="2232438" y="144038"/>
+                </a:lnTo>
+                <a:lnTo>
+                  <a:pt x="2256838" y="157045"/>
+                </a:lnTo>
+                <a:lnTo>
+                  <a:pt x="2280262" y="170537"/>
+                </a:lnTo>
+                <a:lnTo>
+                  <a:pt x="2302688" y="184501"/>
+                </a:lnTo>
+                <a:lnTo>
+                  <a:pt x="2324094" y="198925"/>
+                </a:lnTo>
+                <a:lnTo>
+                  <a:pt x="2344461" y="213794"/>
+                </a:lnTo>
+                <a:lnTo>
+                  <a:pt x="2363770" y="229095"/>
+                </a:lnTo>
+                <a:lnTo>
+                  <a:pt x="2382001" y="244813"/>
+                </a:lnTo>
+                <a:lnTo>
+                  <a:pt x="2399139" y="260934"/>
+                </a:lnTo>
+                <a:lnTo>
+                  <a:pt x="2415167" y="277442"/>
+                </a:lnTo>
+                <a:lnTo>
+                  <a:pt x="2430070" y="294322"/>
+                </a:lnTo>
+                <a:lnTo>
+                  <a:pt x="2443833" y="311558"/>
+                </a:lnTo>
+                <a:lnTo>
+                  <a:pt x="2456445" y="329134"/>
+                </a:lnTo>
+                <a:lnTo>
+                  <a:pt x="2467893" y="347032"/>
+                </a:lnTo>
+                <a:lnTo>
+                  <a:pt x="2478166" y="365238"/>
+                </a:lnTo>
+                <a:lnTo>
+                  <a:pt x="2487254" y="383732"/>
+                </a:lnTo>
+                <a:lnTo>
+                  <a:pt x="2495150" y="402498"/>
+                </a:lnTo>
+                <a:lnTo>
+                  <a:pt x="2501846" y="421519"/>
+                </a:lnTo>
+                <a:lnTo>
+                  <a:pt x="2507334" y="440775"/>
+                </a:lnTo>
+                <a:lnTo>
+                  <a:pt x="2511611" y="460250"/>
+                </a:lnTo>
+                <a:lnTo>
+                  <a:pt x="2514673" y="479925"/>
+                </a:lnTo>
+                <a:lnTo>
+                  <a:pt x="2516515" y="499781"/>
+                </a:lnTo>
+                <a:lnTo>
+                  <a:pt x="2517137" y="519799"/>
+                </a:lnTo>
+                <a:lnTo>
+                  <a:pt x="2516539" y="539962"/>
+                </a:lnTo>
+                <a:lnTo>
+                  <a:pt x="2514719" y="560249"/>
+                </a:lnTo>
+                <a:lnTo>
+                  <a:pt x="2511681" y="580643"/>
+                </a:lnTo>
+                <a:lnTo>
+                  <a:pt x="2507427" y="601122"/>
+                </a:lnTo>
+                <a:lnTo>
+                  <a:pt x="2501962" y="621669"/>
+                </a:lnTo>
+                <a:lnTo>
+                  <a:pt x="2495289" y="642264"/>
+                </a:lnTo>
+                <a:lnTo>
+                  <a:pt x="2487416" y="662888"/>
+                </a:lnTo>
+                <a:lnTo>
+                  <a:pt x="2478350" y="683521"/>
+                </a:lnTo>
+                <a:lnTo>
+                  <a:pt x="2468100" y="704144"/>
+                </a:lnTo>
+              </a:path>
+            </a:pathLst>
+          </a:custGeom>
+          <a:noFill/>
+          <a:ln w="26670">
             <a:solidFill>
-              <a:srgbClr val="576B7E"/>
+              <a:srgbClr val="ED7D31"/>
             </a:solidFill>
           </a:ln>
         </p:spPr>
-      </p:cxnSp>
-      <p:cxnSp>
-        <p:nvCxnSpPr>
-          <p:cNvPr id="36" name="轨迹段0"/>
-          <p:cNvCxnSpPr/>
-          <p:nvPr/>
-        </p:nvCxnSpPr>
-        <p:spPr>
-          <a:xfrm flipV="1">
-            <a:off x="1663700" y="4584700"/>
-            <a:ext cx="774700" cy="203200"/>
-          </a:xfrm>
-          <a:prstGeom prst="line">
-            <a:avLst/>
-          </a:prstGeom>
-          <a:ln w="29210">
-            <a:solidFill>
-              <a:srgbClr val="007EB5"/>
-            </a:solidFill>
-          </a:ln>
-        </p:spPr>
-      </p:cxnSp>
-      <p:cxnSp>
-        <p:nvCxnSpPr>
-          <p:cNvPr id="37" name="轨迹段1"/>
-          <p:cNvCxnSpPr/>
-          <p:nvPr/>
-        </p:nvCxnSpPr>
-        <p:spPr>
-          <a:xfrm flipV="1">
-            <a:off x="2438400" y="4203700"/>
-            <a:ext cx="774700" cy="381000"/>
-          </a:xfrm>
-          <a:prstGeom prst="line">
-            <a:avLst/>
-          </a:prstGeom>
-          <a:ln w="29210">
-            <a:solidFill>
-              <a:srgbClr val="007EB5"/>
-            </a:solidFill>
-          </a:ln>
-        </p:spPr>
-      </p:cxnSp>
-      <p:cxnSp>
-        <p:nvCxnSpPr>
-          <p:cNvPr id="38" name="轨迹段2"/>
-          <p:cNvCxnSpPr/>
-          <p:nvPr/>
-        </p:nvCxnSpPr>
-        <p:spPr>
-          <a:xfrm flipV="1">
-            <a:off x="3213100" y="3644900"/>
-            <a:ext cx="736600" cy="558800"/>
-          </a:xfrm>
-          <a:prstGeom prst="line">
-            <a:avLst/>
-          </a:prstGeom>
-          <a:ln w="29210">
-            <a:solidFill>
-              <a:srgbClr val="007EB5"/>
-            </a:solidFill>
-          </a:ln>
-        </p:spPr>
-      </p:cxnSp>
-      <p:cxnSp>
-        <p:nvCxnSpPr>
-          <p:cNvPr id="39" name="轨迹段3"/>
-          <p:cNvCxnSpPr/>
-          <p:nvPr/>
-        </p:nvCxnSpPr>
-        <p:spPr>
-          <a:xfrm flipV="1">
-            <a:off x="3949700" y="3098800"/>
-            <a:ext cx="647700" cy="546100"/>
-          </a:xfrm>
-          <a:prstGeom prst="line">
-            <a:avLst/>
-          </a:prstGeom>
-          <a:ln w="29210">
-            <a:solidFill>
-              <a:srgbClr val="007EB5"/>
-            </a:solidFill>
-          </a:ln>
-        </p:spPr>
-      </p:cxnSp>
-      <p:cxnSp>
-        <p:nvCxnSpPr>
-          <p:cNvPr id="40" name="轨迹段4"/>
-          <p:cNvCxnSpPr/>
-          <p:nvPr/>
-        </p:nvCxnSpPr>
-        <p:spPr>
-          <a:xfrm flipV="1">
-            <a:off x="4597400" y="2768600"/>
-            <a:ext cx="673100" cy="330200"/>
-          </a:xfrm>
-          <a:prstGeom prst="line">
-            <a:avLst/>
-          </a:prstGeom>
-          <a:ln w="29210">
-            <a:solidFill>
-              <a:srgbClr val="007EB5"/>
-            </a:solidFill>
-            <a:tailEnd type="triangle" w="sm" len="sm"/>
-          </a:ln>
-        </p:spPr>
-      </p:cxnSp>
-      <p:sp>
-        <p:nvSpPr>
-          <p:cNvPr id="41" name="轨迹采样点0"/>
+      </p:sp>
+      <p:sp>
+        <p:nvSpPr>
+          <p:cNvPr id="39" name="固定可见天体_b1"/>
           <p:cNvSpPr txBox="1"/>
           <p:nvPr/>
         </p:nvSpPr>
         <p:spPr>
           <a:xfrm>
-            <a:off x="1612900" y="4737100"/>
-            <a:ext cx="101600" cy="101600"/>
+            <a:off x="1854200" y="4597400"/>
+            <a:ext cx="203200" cy="203200"/>
           </a:xfrm>
           <a:prstGeom prst="ellipse">
             <a:avLst/>
           </a:prstGeom>
           <a:solidFill>
-            <a:srgbClr val="007EB5"/>
+            <a:srgbClr val="0070C0"/>
           </a:solidFill>
           <a:ln w="12700">
             <a:noFill/>
@@ -6916,20 +7318,68 @@
       </p:sp>
       <p:sp>
         <p:nvSpPr>
-          <p:cNvPr id="42" name="轨迹采样点1"/>
+          <p:cNvPr id="40" name="天体标签_b1"/>
           <p:cNvSpPr txBox="1"/>
           <p:nvPr/>
         </p:nvSpPr>
         <p:spPr>
           <a:xfrm>
-            <a:off x="2387600" y="4533900"/>
-            <a:ext cx="101600" cy="101600"/>
+            <a:off x="1574800" y="4889500"/>
+            <a:ext cx="558800" cy="330200"/>
+          </a:xfrm>
+          <a:prstGeom prst="rect">
+            <a:avLst/>
+          </a:prstGeom>
+          <a:noFill/>
+          <a:ln w="12700">
+            <a:noFill/>
+          </a:ln>
+        </p:spPr>
+        <p:txBody>
+          <a:bodyPr wrap="square" lIns="0" rIns="0" tIns="0" bIns="0" anchor="t">
+            <a:noAutofit/>
+          </a:bodyPr>
+          <a:lstStyle/>
+          <a:p>
+            <a:pPr algn="l">
+              <a:lnSpc>
+                <a:spcPct val="110000"/>
+              </a:lnSpc>
+              <a:spcAft>
+                <a:spcPts val="700"/>
+              </a:spcAft>
+              <a:buNone/>
+            </a:pPr>
+            <a:r>
+              <a:rPr lang="zh-CN" sz="1800" b="0" dirty="0">
+                <a:solidFill>
+                  <a:srgbClr val="335693"/>
+                </a:solidFill>
+                <a:latin typeface="微软雅黑"/>
+                <a:ea typeface="微软雅黑"/>
+              </a:rPr>
+              <a:t>b₁</a:t>
+            </a:r>
+            <a:endParaRPr lang="zh-CN" sz="1800"/>
+          </a:p>
+        </p:txBody>
+      </p:sp>
+      <p:sp>
+        <p:nvSpPr>
+          <p:cNvPr id="41" name="固定可见天体_b2"/>
+          <p:cNvSpPr txBox="1"/>
+          <p:nvPr/>
+        </p:nvSpPr>
+        <p:spPr>
+          <a:xfrm>
+            <a:off x="3479800" y="4597400"/>
+            <a:ext cx="203200" cy="203200"/>
           </a:xfrm>
           <a:prstGeom prst="ellipse">
             <a:avLst/>
           </a:prstGeom>
           <a:solidFill>
-            <a:srgbClr val="007EB5"/>
+            <a:srgbClr val="0070C0"/>
           </a:solidFill>
           <a:ln w="12700">
             <a:noFill/>
@@ -6938,20 +7388,68 @@
       </p:sp>
       <p:sp>
         <p:nvSpPr>
-          <p:cNvPr id="43" name="轨迹采样点2"/>
+          <p:cNvPr id="42" name="天体标签_b2"/>
           <p:cNvSpPr txBox="1"/>
           <p:nvPr/>
         </p:nvSpPr>
         <p:spPr>
           <a:xfrm>
-            <a:off x="3162300" y="4152900"/>
-            <a:ext cx="101600" cy="101600"/>
+            <a:off x="3695700" y="4889500"/>
+            <a:ext cx="558800" cy="330200"/>
+          </a:xfrm>
+          <a:prstGeom prst="rect">
+            <a:avLst/>
+          </a:prstGeom>
+          <a:noFill/>
+          <a:ln w="12700">
+            <a:noFill/>
+          </a:ln>
+        </p:spPr>
+        <p:txBody>
+          <a:bodyPr wrap="square" lIns="0" rIns="0" tIns="0" bIns="0" anchor="t">
+            <a:noAutofit/>
+          </a:bodyPr>
+          <a:lstStyle/>
+          <a:p>
+            <a:pPr algn="l">
+              <a:lnSpc>
+                <a:spcPct val="110000"/>
+              </a:lnSpc>
+              <a:spcAft>
+                <a:spcPts val="700"/>
+              </a:spcAft>
+              <a:buNone/>
+            </a:pPr>
+            <a:r>
+              <a:rPr lang="zh-CN" sz="1800" b="0" dirty="0">
+                <a:solidFill>
+                  <a:srgbClr val="335693"/>
+                </a:solidFill>
+                <a:latin typeface="微软雅黑"/>
+                <a:ea typeface="微软雅黑"/>
+              </a:rPr>
+              <a:t>b₂</a:t>
+            </a:r>
+            <a:endParaRPr lang="zh-CN" sz="1800"/>
+          </a:p>
+        </p:txBody>
+      </p:sp>
+      <p:sp>
+        <p:nvSpPr>
+          <p:cNvPr id="43" name="固定可见天体_b3"/>
+          <p:cNvSpPr txBox="1"/>
+          <p:nvPr/>
+        </p:nvSpPr>
+        <p:spPr>
+          <a:xfrm>
+            <a:off x="2667000" y="3378200"/>
+            <a:ext cx="203200" cy="203200"/>
           </a:xfrm>
           <a:prstGeom prst="ellipse">
             <a:avLst/>
           </a:prstGeom>
           <a:solidFill>
-            <a:srgbClr val="007EB5"/>
+            <a:srgbClr val="0070C0"/>
           </a:solidFill>
           <a:ln w="12700">
             <a:noFill/>
@@ -6960,80 +7458,62 @@
       </p:sp>
       <p:sp>
         <p:nvSpPr>
-          <p:cNvPr id="44" name="轨迹采样点3"/>
+          <p:cNvPr id="44" name="天体标签_b3"/>
           <p:cNvSpPr txBox="1"/>
           <p:nvPr/>
         </p:nvSpPr>
         <p:spPr>
           <a:xfrm>
-            <a:off x="3898900" y="3594100"/>
-            <a:ext cx="101600" cy="101600"/>
-          </a:xfrm>
-          <a:prstGeom prst="ellipse">
+            <a:off x="2933700" y="3162300"/>
+            <a:ext cx="558800" cy="330200"/>
+          </a:xfrm>
+          <a:prstGeom prst="rect">
             <a:avLst/>
           </a:prstGeom>
-          <a:solidFill>
-            <a:srgbClr val="007EB5"/>
-          </a:solidFill>
+          <a:noFill/>
           <a:ln w="12700">
             <a:noFill/>
           </a:ln>
         </p:spPr>
-      </p:sp>
-      <p:sp>
-        <p:nvSpPr>
-          <p:cNvPr id="45" name="轨迹采样点4"/>
+        <p:txBody>
+          <a:bodyPr wrap="square" lIns="0" rIns="0" tIns="0" bIns="0" anchor="t">
+            <a:noAutofit/>
+          </a:bodyPr>
+          <a:lstStyle/>
+          <a:p>
+            <a:pPr algn="l">
+              <a:lnSpc>
+                <a:spcPct val="110000"/>
+              </a:lnSpc>
+              <a:spcAft>
+                <a:spcPts val="700"/>
+              </a:spcAft>
+              <a:buNone/>
+            </a:pPr>
+            <a:r>
+              <a:rPr lang="zh-CN" sz="1800" b="0" dirty="0">
+                <a:solidFill>
+                  <a:srgbClr val="335693"/>
+                </a:solidFill>
+                <a:latin typeface="微软雅黑"/>
+                <a:ea typeface="微软雅黑"/>
+              </a:rPr>
+              <a:t>b₃</a:t>
+            </a:r>
+            <a:endParaRPr lang="zh-CN" sz="1800"/>
+          </a:p>
+        </p:txBody>
+      </p:sp>
+      <p:sp>
+        <p:nvSpPr>
+          <p:cNvPr id="45" name="探针采样时刻_0"/>
           <p:cNvSpPr txBox="1"/>
           <p:nvPr/>
         </p:nvSpPr>
         <p:spPr>
           <a:xfrm>
-            <a:off x="4546600" y="3048000"/>
-            <a:ext cx="101600" cy="101600"/>
-          </a:xfrm>
-          <a:prstGeom prst="ellipse">
-            <a:avLst/>
-          </a:prstGeom>
-          <a:solidFill>
-            <a:srgbClr val="007EB5"/>
-          </a:solidFill>
-          <a:ln w="12700">
-            <a:noFill/>
-          </a:ln>
-        </p:spPr>
-      </p:sp>
-      <p:sp>
-        <p:nvSpPr>
-          <p:cNvPr id="46" name="轨迹采样点5"/>
-          <p:cNvSpPr txBox="1"/>
-          <p:nvPr/>
-        </p:nvSpPr>
-        <p:spPr>
-          <a:xfrm>
-            <a:off x="5219700" y="2717800"/>
-            <a:ext cx="101600" cy="101600"/>
-          </a:xfrm>
-          <a:prstGeom prst="ellipse">
-            <a:avLst/>
-          </a:prstGeom>
-          <a:solidFill>
-            <a:srgbClr val="007EB5"/>
-          </a:solidFill>
-          <a:ln w="12700">
-            <a:noFill/>
-          </a:ln>
-        </p:spPr>
-      </p:sp>
-      <p:sp>
-        <p:nvSpPr>
-          <p:cNvPr id="47" name="初始探针"/>
-          <p:cNvSpPr txBox="1"/>
-          <p:nvPr/>
-        </p:nvSpPr>
-        <p:spPr>
-          <a:xfrm>
-            <a:off x="1574800" y="4699000"/>
-            <a:ext cx="177800" cy="177800"/>
+            <a:off x="1489710" y="4151630"/>
+            <a:ext cx="119380" cy="119380"/>
           </a:xfrm>
           <a:prstGeom prst="ellipse">
             <a:avLst/>
@@ -7046,38 +7526,126 @@
           </a:ln>
         </p:spPr>
       </p:sp>
-      <p:cxnSp>
-        <p:nvCxnSpPr>
-          <p:cNvPr id="48" name="初速度箭头"/>
-          <p:cNvCxnSpPr/>
+      <p:sp>
+        <p:nvSpPr>
+          <p:cNvPr id="46" name="探针采样时刻_1"/>
+          <p:cNvSpPr txBox="1"/>
           <p:nvPr/>
-        </p:nvCxnSpPr>
-        <p:spPr>
-          <a:xfrm>
-            <a:off x="1676400" y="4787900"/>
-            <a:ext cx="876300" cy="165100"/>
-          </a:xfrm>
-          <a:prstGeom prst="line">
+        </p:nvSpPr>
+        <p:spPr>
+          <a:xfrm>
+            <a:off x="1982272" y="3795983"/>
+            <a:ext cx="91440" cy="91440"/>
+          </a:xfrm>
+          <a:prstGeom prst="ellipse">
             <a:avLst/>
           </a:prstGeom>
-          <a:ln w="25400">
-            <a:solidFill>
-              <a:srgbClr val="ED7D31"/>
-            </a:solidFill>
-            <a:tailEnd type="triangle" w="sm" len="sm"/>
+          <a:solidFill>
+            <a:srgbClr val="ED7D31"/>
+          </a:solidFill>
+          <a:ln w="12700">
+            <a:noFill/>
           </a:ln>
         </p:spPr>
-      </p:cxnSp>
-      <p:sp>
-        <p:nvSpPr>
-          <p:cNvPr id="49" name="初速度标记"/>
+      </p:sp>
+      <p:sp>
+        <p:nvSpPr>
+          <p:cNvPr id="47" name="探针采样时刻_2"/>
           <p:cNvSpPr txBox="1"/>
           <p:nvPr/>
         </p:nvSpPr>
         <p:spPr>
           <a:xfrm>
-            <a:off x="2616200" y="4813300"/>
-            <a:ext cx="1066800" cy="330200"/>
+            <a:off x="2730938" y="3590793"/>
+            <a:ext cx="91440" cy="91440"/>
+          </a:xfrm>
+          <a:prstGeom prst="ellipse">
+            <a:avLst/>
+          </a:prstGeom>
+          <a:solidFill>
+            <a:srgbClr val="ED7D31"/>
+          </a:solidFill>
+          <a:ln w="12700">
+            <a:noFill/>
+          </a:ln>
+        </p:spPr>
+      </p:sp>
+      <p:sp>
+        <p:nvSpPr>
+          <p:cNvPr id="48" name="探针采样时刻_3"/>
+          <p:cNvSpPr txBox="1"/>
+          <p:nvPr/>
+        </p:nvSpPr>
+        <p:spPr>
+          <a:xfrm>
+            <a:off x="3476665" y="3624855"/>
+            <a:ext cx="91440" cy="91440"/>
+          </a:xfrm>
+          <a:prstGeom prst="ellipse">
+            <a:avLst/>
+          </a:prstGeom>
+          <a:solidFill>
+            <a:srgbClr val="ED7D31"/>
+          </a:solidFill>
+          <a:ln w="12700">
+            <a:noFill/>
+          </a:ln>
+        </p:spPr>
+      </p:sp>
+      <p:sp>
+        <p:nvSpPr>
+          <p:cNvPr id="49" name="探针采样时刻_4"/>
+          <p:cNvSpPr txBox="1"/>
+          <p:nvPr/>
+        </p:nvSpPr>
+        <p:spPr>
+          <a:xfrm>
+            <a:off x="3947513" y="3885748"/>
+            <a:ext cx="91440" cy="91440"/>
+          </a:xfrm>
+          <a:prstGeom prst="ellipse">
+            <a:avLst/>
+          </a:prstGeom>
+          <a:solidFill>
+            <a:srgbClr val="ED7D31"/>
+          </a:solidFill>
+          <a:ln w="12700">
+            <a:noFill/>
+          </a:ln>
+        </p:spPr>
+      </p:sp>
+      <p:sp>
+        <p:nvSpPr>
+          <p:cNvPr id="50" name="探针采样时刻_5"/>
+          <p:cNvSpPr txBox="1"/>
+          <p:nvPr/>
+        </p:nvSpPr>
+        <p:spPr>
+          <a:xfrm>
+            <a:off x="3971780" y="4278334"/>
+            <a:ext cx="91440" cy="91440"/>
+          </a:xfrm>
+          <a:prstGeom prst="ellipse">
+            <a:avLst/>
+          </a:prstGeom>
+          <a:solidFill>
+            <a:srgbClr val="ED7D31"/>
+          </a:solidFill>
+          <a:ln w="12700">
+            <a:noFill/>
+          </a:ln>
+        </p:spPr>
+      </p:sp>
+      <p:sp>
+        <p:nvSpPr>
+          <p:cNvPr id="51" name="运动探针标记"/>
+          <p:cNvSpPr txBox="1"/>
+          <p:nvPr/>
+        </p:nvSpPr>
+        <p:spPr>
+          <a:xfrm>
+            <a:off x="990600" y="4356100"/>
+            <a:ext cx="914400" cy="330200"/>
           </a:xfrm>
           <a:prstGeom prst="rect">
             <a:avLst/>
@@ -7105,366 +7673,12 @@
             <a:r>
               <a:rPr lang="zh-CN" sz="1700" b="0" dirty="0">
                 <a:solidFill>
-                  <a:srgbClr val="BD581F"/>
+                  <a:srgbClr val="B4561B"/>
                 </a:solidFill>
                 <a:latin typeface="微软雅黑"/>
                 <a:ea typeface="微软雅黑"/>
               </a:rPr>
-              <a:t>初速度</a:t>
-            </a:r>
-            <a:endParaRPr lang="zh-CN" sz="1700"/>
-          </a:p>
-        </p:txBody>
-      </p:sp>
-      <p:sp>
-        <p:nvSpPr>
-          <p:cNvPr id="50" name="轨迹标记"/>
-          <p:cNvSpPr txBox="1"/>
-          <p:nvPr/>
-        </p:nvSpPr>
-        <p:spPr>
-          <a:xfrm>
-            <a:off x="3162300" y="4229100"/>
-            <a:ext cx="2895600" cy="355600"/>
-          </a:xfrm>
-          <a:prstGeom prst="rect">
-            <a:avLst/>
-          </a:prstGeom>
-          <a:noFill/>
-          <a:ln w="12700">
-            <a:noFill/>
-          </a:ln>
-        </p:spPr>
-        <p:txBody>
-          <a:bodyPr wrap="square" lIns="0" rIns="0" tIns="0" bIns="0" anchor="t">
-            <a:noAutofit/>
-          </a:bodyPr>
-          <a:lstStyle/>
-          <a:p>
-            <a:pPr algn="l">
-              <a:lnSpc>
-                <a:spcPct val="110000"/>
-              </a:lnSpc>
-              <a:spcAft>
-                <a:spcPts val="700"/>
-              </a:spcAft>
-              <a:buNone/>
-            </a:pPr>
-            <a:r>
-              <a:rPr lang="zh-CN" sz="1800" b="0" dirty="0">
-                <a:solidFill>
-                  <a:srgbClr val="335693"/>
-                </a:solidFill>
-                <a:latin typeface="微软雅黑"/>
-                <a:ea typeface="微软雅黑"/>
-              </a:rPr>
-              <a:t>探针轨迹与采样读数</a:t>
-            </a:r>
-            <a:endParaRPr lang="zh-CN" sz="1800"/>
-          </a:p>
-        </p:txBody>
-      </p:sp>
-      <p:sp>
-        <p:nvSpPr>
-          <p:cNvPr id="51" name="控制项目标题"/>
-          <p:cNvSpPr txBox="1"/>
-          <p:nvPr/>
-        </p:nvSpPr>
-        <p:spPr>
-          <a:xfrm>
-            <a:off x="6794500" y="1714500"/>
-            <a:ext cx="4572000" cy="431800"/>
-          </a:xfrm>
-          <a:prstGeom prst="rect">
-            <a:avLst/>
-          </a:prstGeom>
-          <a:noFill/>
-          <a:ln w="12700">
-            <a:noFill/>
-          </a:ln>
-        </p:spPr>
-        <p:txBody>
-          <a:bodyPr wrap="square" lIns="0" rIns="0" tIns="0" bIns="0" anchor="t">
-            <a:noAutofit/>
-          </a:bodyPr>
-          <a:lstStyle/>
-          <a:p>
-            <a:pPr algn="l">
-              <a:lnSpc>
-                <a:spcPct val="110000"/>
-              </a:lnSpc>
-              <a:spcAft>
-                <a:spcPts val="700"/>
-              </a:spcAft>
-              <a:buNone/>
-            </a:pPr>
-            <a:r>
-              <a:rPr lang="zh-CN" sz="2500" b="1" dirty="0">
-                <a:solidFill>
-                  <a:srgbClr val="335693"/>
-                </a:solidFill>
-                <a:latin typeface="微软雅黑"/>
-                <a:ea typeface="微软雅黑"/>
-              </a:rPr>
-              <a:t>可以控制什么？</a:t>
-            </a:r>
-            <a:endParaRPr lang="zh-CN" sz="2500"/>
-          </a:p>
-        </p:txBody>
-      </p:sp>
-      <p:sp>
-        <p:nvSpPr>
-          <p:cNvPr id="52" name="控制项目"/>
-          <p:cNvSpPr txBox="1"/>
-          <p:nvPr/>
-        </p:nvSpPr>
-        <p:spPr>
-          <a:xfrm>
-            <a:off x="6794500" y="2387600"/>
-            <a:ext cx="4699000" cy="1803400"/>
-          </a:xfrm>
-          <a:prstGeom prst="rect">
-            <a:avLst/>
-          </a:prstGeom>
-          <a:noFill/>
-          <a:ln w="12700">
-            <a:noFill/>
-          </a:ln>
-        </p:spPr>
-        <p:txBody>
-          <a:bodyPr wrap="square" lIns="0" rIns="0" tIns="0" bIns="0" anchor="t">
-            <a:noAutofit/>
-          </a:bodyPr>
-          <a:lstStyle/>
-          <a:p>
-            <a:pPr algn="l">
-              <a:lnSpc>
-                <a:spcPct val="110000"/>
-              </a:lnSpc>
-              <a:spcAft>
-                <a:spcPts val="700"/>
-              </a:spcAft>
-              <a:buNone/>
-            </a:pPr>
-            <a:r>
-              <a:rPr lang="zh-CN" sz="2300" b="0" dirty="0">
-                <a:solidFill>
-                  <a:srgbClr val="243746"/>
-                </a:solidFill>
-                <a:latin typeface="微软雅黑"/>
-                <a:ea typeface="微软雅黑"/>
-              </a:rPr>
-              <a:t>探针数量、初始位置和速度</a:t>
-            </a:r>
-            <a:endParaRPr lang="zh-CN" sz="2300"/>
-          </a:p>
-          <a:p>
-            <a:pPr algn="l">
-              <a:lnSpc>
-                <a:spcPct val="110000"/>
-              </a:lnSpc>
-              <a:spcAft>
-                <a:spcPts val="700"/>
-              </a:spcAft>
-              <a:buNone/>
-            </a:pPr>
-            <a:r>
-              <a:rPr lang="zh-CN" sz="2300" b="0" dirty="0">
-                <a:solidFill>
-                  <a:srgbClr val="243746"/>
-                </a:solidFill>
-                <a:latin typeface="微软雅黑"/>
-                <a:ea typeface="微软雅黑"/>
-              </a:rPr>
-              <a:t>投放时刻</a:t>
-            </a:r>
-            <a:endParaRPr lang="zh-CN" sz="2300"/>
-          </a:p>
-          <a:p>
-            <a:pPr algn="l">
-              <a:lnSpc>
-                <a:spcPct val="110000"/>
-              </a:lnSpc>
-              <a:spcAft>
-                <a:spcPts val="700"/>
-              </a:spcAft>
-              <a:buNone/>
-            </a:pPr>
-            <a:r>
-              <a:rPr lang="zh-CN" sz="2300" b="0" dirty="0">
-                <a:solidFill>
-                  <a:srgbClr val="243746"/>
-                </a:solidFill>
-                <a:latin typeface="微软雅黑"/>
-                <a:ea typeface="微软雅黑"/>
-              </a:rPr>
-              <a:t>各宇宙协议开放的标量属性</a:t>
-            </a:r>
-            <a:endParaRPr lang="zh-CN" sz="2300"/>
-          </a:p>
-        </p:txBody>
-      </p:sp>
-      <p:sp>
-        <p:nvSpPr>
-          <p:cNvPr id="53" name="返回内容标题"/>
-          <p:cNvSpPr txBox="1"/>
-          <p:nvPr/>
-        </p:nvSpPr>
-        <p:spPr>
-          <a:xfrm>
-            <a:off x="6794500" y="4406900"/>
-            <a:ext cx="4572000" cy="431800"/>
-          </a:xfrm>
-          <a:prstGeom prst="rect">
-            <a:avLst/>
-          </a:prstGeom>
-          <a:noFill/>
-          <a:ln w="12700">
-            <a:noFill/>
-          </a:ln>
-        </p:spPr>
-        <p:txBody>
-          <a:bodyPr wrap="square" lIns="0" rIns="0" tIns="0" bIns="0" anchor="t">
-            <a:noAutofit/>
-          </a:bodyPr>
-          <a:lstStyle/>
-          <a:p>
-            <a:pPr algn="l">
-              <a:lnSpc>
-                <a:spcPct val="110000"/>
-              </a:lnSpc>
-              <a:spcAft>
-                <a:spcPts val="700"/>
-              </a:spcAft>
-              <a:buNone/>
-            </a:pPr>
-            <a:r>
-              <a:rPr lang="zh-CN" sz="2500" b="1" dirty="0">
-                <a:solidFill>
-                  <a:srgbClr val="335693"/>
-                </a:solidFill>
-                <a:latin typeface="微软雅黑"/>
-                <a:ea typeface="微软雅黑"/>
-              </a:rPr>
-              <a:t>可以看到什么？</a:t>
-            </a:r>
-            <a:endParaRPr lang="zh-CN" sz="2500"/>
-          </a:p>
-        </p:txBody>
-      </p:sp>
-      <p:sp>
-        <p:nvSpPr>
-          <p:cNvPr id="54" name="返回内容"/>
-          <p:cNvSpPr txBox="1"/>
-          <p:nvPr/>
-        </p:nvSpPr>
-        <p:spPr>
-          <a:xfrm>
-            <a:off x="6794500" y="4991100"/>
-            <a:ext cx="4699000" cy="990600"/>
-          </a:xfrm>
-          <a:prstGeom prst="rect">
-            <a:avLst/>
-          </a:prstGeom>
-          <a:noFill/>
-          <a:ln w="12700">
-            <a:noFill/>
-          </a:ln>
-        </p:spPr>
-        <p:txBody>
-          <a:bodyPr wrap="square" lIns="0" rIns="0" tIns="0" bIns="0" anchor="t">
-            <a:noAutofit/>
-          </a:bodyPr>
-          <a:lstStyle/>
-          <a:p>
-            <a:pPr algn="l">
-              <a:lnSpc>
-                <a:spcPct val="110000"/>
-              </a:lnSpc>
-              <a:spcAft>
-                <a:spcPts val="700"/>
-              </a:spcAft>
-              <a:buNone/>
-            </a:pPr>
-            <a:r>
-              <a:rPr lang="zh-CN" sz="2200" b="0" dirty="0">
-                <a:solidFill>
-                  <a:srgbClr val="243746"/>
-                </a:solidFill>
-                <a:latin typeface="微软雅黑"/>
-                <a:ea typeface="微软雅黑"/>
-              </a:rPr>
-              <a:t>探针的位置、速度与实际时刻</a:t>
-            </a:r>
-            <a:endParaRPr lang="zh-CN" sz="2200"/>
-          </a:p>
-          <a:p>
-            <a:pPr algn="l">
-              <a:lnSpc>
-                <a:spcPct val="110000"/>
-              </a:lnSpc>
-              <a:spcAft>
-                <a:spcPts val="700"/>
-              </a:spcAft>
-              <a:buNone/>
-            </a:pPr>
-            <a:r>
-              <a:rPr lang="zh-CN" sz="2200" b="0" dirty="0">
-                <a:solidFill>
-                  <a:srgbClr val="243746"/>
-                </a:solidFill>
-                <a:latin typeface="微软雅黑"/>
-                <a:ea typeface="微软雅黑"/>
-              </a:rPr>
-              <a:t>以及可见背景的观测记录</a:t>
-            </a:r>
-            <a:endParaRPr lang="zh-CN" sz="2200"/>
-          </a:p>
-        </p:txBody>
-      </p:sp>
-      <p:sp>
-        <p:nvSpPr>
-          <p:cNvPr id="55" name="被动性"/>
-          <p:cNvSpPr txBox="1"/>
-          <p:nvPr/>
-        </p:nvSpPr>
-        <p:spPr>
-          <a:xfrm>
-            <a:off x="762000" y="6134100"/>
-            <a:ext cx="10668000" cy="495300"/>
-          </a:xfrm>
-          <a:prstGeom prst="rect">
-            <a:avLst/>
-          </a:prstGeom>
-          <a:noFill/>
-          <a:ln w="12700">
-            <a:noFill/>
-          </a:ln>
-        </p:spPr>
-        <p:txBody>
-          <a:bodyPr wrap="square" lIns="0" rIns="0" tIns="0" bIns="0" anchor="t">
-            <a:noAutofit/>
-          </a:bodyPr>
-          <a:lstStyle/>
-          <a:p>
-            <a:pPr algn="l">
-              <a:lnSpc>
-                <a:spcPct val="110000"/>
-              </a:lnSpc>
-              <a:spcAft>
-                <a:spcPts val="700"/>
-              </a:spcAft>
-              <a:buNone/>
-            </a:pPr>
-            <a:r>
-              <a:rPr lang="zh-CN" sz="1700" b="0" dirty="0">
-                <a:solidFill>
-                  <a:srgbClr val="576B7E"/>
-                </a:solidFill>
-                <a:latin typeface="微软雅黑"/>
-                <a:ea typeface="微软雅黑"/>
-              </a:rPr>
-              <a:t>探针独立运动，不相互作用，也不改变背景；位置带噪声，速度不额外加噪声。</a:t>
+              <a:t>探针 r</a:t>
             </a:r>
             <a:endParaRPr lang="zh-CN" sz="1700"/>
           </a:p>

</xml_diff>